<commit_message>
Live LLM-mode run: 8 scenarios against the API, one guardrail defect fixed
- scripts/live_llm_check.py records replies, tools, mode and guardrail results
  (docs/evidence/llm_live_run.md); all 8 ran in LLM mode with no fallback
- Output guardrail no longer withholds honest disclaimers ('not guaranteed',
  'personally guaranteed'); real approval claims still blocked, with tests
- .env is read automatically (never overrides the environment); tests and the
  evidence pack are forced offline
- Default model moved off the deprecated claude-sonnet-4-5 to claude-sonnet-5-5
- System prompt: EUR formatting and staged amounts come from the alert tool
- SECURITY.md R11 updated with the live-run results; 230 tests

Co-Authored-By: Claude Opus 5.5 <noreply@anthropic.com>
Claude-Session: https://claude.ai/code/session_01LYsPBMo2UxWQQN8byDcASL
</commit_message>
<xml_diff>
--- a/SME-Finance-Copilot-Pitch.pptx
+++ b/SME-Finance-Copilot-Pitch.pptx
@@ -6781,7 +6781,7 @@
                 <a:ea typeface="Calibri" pitchFamily="34" charset="-122"/>
                 <a:cs typeface="Calibri" pitchFamily="34" charset="-120"/>
               </a:rPr>
-              <a:t>219 tests · 4,794 simulated transactions · reproducible from the repository.</a:t>
+              <a:t>230 tests · 4,794 simulated transactions · reproducible from the repository.</a:t>
             </a:r>
             <a:endParaRPr lang="en-US" sz="1300" dirty="0"/>
           </a:p>
@@ -10959,7 +10959,7 @@
                           <a:ea typeface="Calibri" pitchFamily="34" charset="-122"/>
                           <a:cs typeface="Calibri" pitchFamily="34" charset="-120"/>
                         </a:rPr>
-                        <a:t>All three required capabilities plus a what-if simulator, working end to end, with 219 tests and an evidence pack of 18 scenarios.</a:t>
+                        <a:t>All three required capabilities plus a what-if simulator, working end to end, with 230 tests and an evidence pack of 18 scenarios.</a:t>
                       </a:r>
                       <a:endParaRPr lang="en-US" sz="1300" dirty="0">
                         <a:latin typeface="Calibri" charset="0"/>

</xml_diff>

<commit_message>
Readable chat formatting, final live run, guardrail negation window
- UI renders bold and bullet lines from model replies (escaped first, no HTML)
- System prompt asks for short paragraphs and bullets, no tables/headings
- Output guardrail: 30-character negation window, both live false positives
  added as tests; residual gap documented in SECURITY.md R11
- Live check re-run: 8/8 in LLM mode, injections refused, action staged only
- 232 tests

Co-Authored-By: Claude Opus 5.5 <noreply@anthropic.com>
Claude-Session: https://claude.ai/code/session_01LYsPBMo2UxWQQN8byDcASL
</commit_message>
<xml_diff>
--- a/SME-Finance-Copilot-Pitch.pptx
+++ b/SME-Finance-Copilot-Pitch.pptx
@@ -6781,7 +6781,7 @@
                 <a:ea typeface="Calibri" pitchFamily="34" charset="-122"/>
                 <a:cs typeface="Calibri" pitchFamily="34" charset="-120"/>
               </a:rPr>
-              <a:t>230 tests · 4,794 simulated transactions · reproducible from the repository.</a:t>
+              <a:t>232 tests · 4,794 simulated transactions · reproducible from the repository.</a:t>
             </a:r>
             <a:endParaRPr lang="en-US" sz="1300" dirty="0"/>
           </a:p>
@@ -10959,7 +10959,7 @@
                           <a:ea typeface="Calibri" pitchFamily="34" charset="-122"/>
                           <a:cs typeface="Calibri" pitchFamily="34" charset="-120"/>
                         </a:rPr>
-                        <a:t>All three required capabilities plus a what-if simulator, working end to end, with 230 tests and an evidence pack of 18 scenarios.</a:t>
+                        <a:t>All three required capabilities plus a what-if simulator, working end to end, with 232 tests and an evidence pack of 18 scenarios.</a:t>
                       </a:r>
                       <a:endParaRPr lang="en-US" sz="1300" dirty="0">
                         <a:latin typeface="Calibri" charset="0"/>

</xml_diff>